<commit_message>
Add sensitivity guardrails, unauthorized fallback, admin label control, and guardrail slide
</commit_message>
<xml_diff>
--- a/Policy_Sarthi_Jury_Presentation.pptx
+++ b/Policy_Sarthi_Jury_Presentation.pptx
@@ -18,6 +18,7 @@
     <p:sldId id="266" r:id="rId17"/>
     <p:sldId id="267" r:id="rId18"/>
     <p:sldId id="268" r:id="rId19"/>
+    <p:sldId id="269" r:id="rId20"/>
   </p:sldIdLst>
   <p:sldSz cx="12191695" cy="6858000" type="screen4x3"/>
   <p:notesSz cx="6858000" cy="9144000"/>
@@ -3678,7 +3679,7 @@
                   <a:srgbClr val="182C4D"/>
                 </a:solidFill>
               </a:rPr>
-              <a:t>Scalability Roadmap</a:t>
+              <a:t>Deployment Plan</a:t>
             </a:r>
           </a:p>
         </p:txBody>
@@ -3754,7 +3755,7 @@
                   <a:srgbClr val="59636E"/>
                 </a:solidFill>
               </a:rPr>
-              <a:t>How we scale from pilot to enterprise</a:t>
+              <a:t>Where and how Policy Sarthi will run</a:t>
             </a:r>
           </a:p>
         </p:txBody>
@@ -3768,7 +3769,7 @@
         <p:spPr>
           <a:xfrm>
             <a:off x="731520" y="1554480"/>
-            <a:ext cx="3566160" cy="3291840"/>
+            <a:ext cx="3474720" cy="2194560"/>
           </a:xfrm>
           <a:prstGeom prst="roundRect">
             <a:avLst/>
@@ -3813,7 +3814,7 @@
         <p:spPr>
           <a:xfrm>
             <a:off x="868680" y="1645920"/>
-            <a:ext cx="3291840" cy="320040"/>
+            <a:ext cx="3200400" cy="320040"/>
           </a:xfrm>
           <a:prstGeom prst="rect">
             <a:avLst/>
@@ -3832,7 +3833,7 @@
                   <a:srgbClr val="182C4D"/>
                 </a:solidFill>
               </a:rPr>
-              <a:t>Phase 1 (Now)</a:t>
+              <a:t>MVP Deployment</a:t>
             </a:r>
           </a:p>
         </p:txBody>
@@ -3846,7 +3847,7 @@
         <p:spPr>
           <a:xfrm>
             <a:off x="868680" y="1965960"/>
-            <a:ext cx="3291840" cy="2788920"/>
+            <a:ext cx="3200400" cy="1691640"/>
           </a:xfrm>
           <a:prstGeom prst="rect">
             <a:avLst/>
@@ -3865,9 +3866,9 @@
                   <a:srgbClr val="182C4D"/>
                 </a:solidFill>
               </a:rPr>
-              <a:t>SQLite + local storage
-Single service deployment
-Hospital-level pilot</a:t>
+              <a:t>Single VM/Container
+Frontend + Backend behind reverse proxy
+Managed secrets for Sarvam key</a:t>
             </a:r>
           </a:p>
         </p:txBody>
@@ -3881,7 +3882,7 @@
         <p:spPr>
           <a:xfrm>
             <a:off x="4526280" y="1554480"/>
-            <a:ext cx="3566160" cy="3291840"/>
+            <a:ext cx="3474720" cy="2194560"/>
           </a:xfrm>
           <a:prstGeom prst="roundRect">
             <a:avLst/>
@@ -3926,7 +3927,7 @@
         <p:spPr>
           <a:xfrm>
             <a:off x="4663440" y="1645920"/>
-            <a:ext cx="3291840" cy="320040"/>
+            <a:ext cx="3200400" cy="320040"/>
           </a:xfrm>
           <a:prstGeom prst="rect">
             <a:avLst/>
@@ -3945,7 +3946,7 @@
                   <a:srgbClr val="182C4D"/>
                 </a:solidFill>
               </a:rPr>
-              <a:t>Phase 2</a:t>
+              <a:t>Preferred Cloud</a:t>
             </a:r>
           </a:p>
         </p:txBody>
@@ -3959,7 +3960,7 @@
         <p:spPr>
           <a:xfrm>
             <a:off x="4663440" y="1965960"/>
-            <a:ext cx="3291840" cy="2788920"/>
+            <a:ext cx="3200400" cy="1691640"/>
           </a:xfrm>
           <a:prstGeom prst="rect">
             <a:avLst/>
@@ -3978,10 +3979,9 @@
                   <a:srgbClr val="182C4D"/>
                 </a:solidFill>
               </a:rPr>
-              <a:t>Postgres + Redis caching
-Vector DB (Milvus/Pinecone)
-Async workers for ingestion
-Multi-hospital tenancy</a:t>
+              <a:t>Azure / AWS / GCP
+App service + managed DB + object storage
+CI/CD via GitHub Actions</a:t>
             </a:r>
           </a:p>
         </p:txBody>
@@ -3995,7 +3995,7 @@
         <p:spPr>
           <a:xfrm>
             <a:off x="8321040" y="1554480"/>
-            <a:ext cx="3108960" cy="3291840"/>
+            <a:ext cx="3108960" cy="2194560"/>
           </a:xfrm>
           <a:prstGeom prst="roundRect">
             <a:avLst/>
@@ -4059,7 +4059,7 @@
                   <a:srgbClr val="182C4D"/>
                 </a:solidFill>
               </a:rPr>
-              <a:t>Phase 3</a:t>
+              <a:t>Hospital Integration</a:t>
             </a:r>
           </a:p>
         </p:txBody>
@@ -4073,7 +4073,7 @@
         <p:spPr>
           <a:xfrm>
             <a:off x="8458200" y="1965960"/>
-            <a:ext cx="2834640" cy="2788920"/>
+            <a:ext cx="2834640" cy="1691640"/>
           </a:xfrm>
           <a:prstGeom prst="rect">
             <a:avLst/>
@@ -4092,10 +4092,56 @@
                   <a:srgbClr val="182C4D"/>
                 </a:solidFill>
               </a:rPr>
-              <a:t>Horizontal autoscaling
-Regional failover
-Model routing + cost controls
-SLA/SLO observability</a:t>
+              <a:t>VPN/private network
+SSO with hospital IAM
+Audit export to SIEM</a:t>
+            </a:r>
+          </a:p>
+        </p:txBody>
+      </p:sp>
+      <p:sp>
+        <p:nvSpPr>
+          <p:cNvPr id="14" name="TextBox 13"/>
+          <p:cNvSpPr txBox="1"/>
+          <p:nvPr/>
+        </p:nvSpPr>
+        <p:spPr>
+          <a:xfrm>
+            <a:off x="731520" y="4069080"/>
+            <a:ext cx="10698480" cy="1188720"/>
+          </a:xfrm>
+          <a:prstGeom prst="rect">
+            <a:avLst/>
+          </a:prstGeom>
+          <a:noFill/>
+        </p:spPr>
+        <p:txBody>
+          <a:bodyPr wrap="square">
+            <a:spAutoFit/>
+          </a:bodyPr>
+          <a:lstStyle/>
+          <a:p>
+            <a:pPr>
+              <a:defRPr sz="1400">
+                <a:solidFill>
+                  <a:srgbClr val="182C4D"/>
+                </a:solidFill>
+              </a:defRPr>
+            </a:pPr>
+            <a:r>
+              <a:t>Target environments: staging (UAT) -&gt; production with change approvals.</a:t>
+            </a:r>
+          </a:p>
+          <a:p>
+            <a:pPr>
+              <a:defRPr sz="1400">
+                <a:solidFill>
+                  <a:srgbClr val="182C4D"/>
+                </a:solidFill>
+              </a:defRPr>
+            </a:pPr>
+            <a:r>
+              <a:t>Secrets, logs, and backups managed through cloud-native services.</a:t>
             </a:r>
           </a:p>
         </p:txBody>
@@ -4154,7 +4200,7 @@
                   <a:srgbClr val="182C4D"/>
                 </a:solidFill>
               </a:rPr>
-              <a:t>Success Metrics</a:t>
+              <a:t>Scalability Roadmap</a:t>
             </a:r>
           </a:p>
         </p:txBody>
@@ -4230,7 +4276,7 @@
                   <a:srgbClr val="59636E"/>
                 </a:solidFill>
               </a:rPr>
-              <a:t>What we will measure post-deployment</a:t>
+              <a:t>How we scale from pilot to enterprise</a:t>
             </a:r>
           </a:p>
         </p:txBody>
@@ -4244,7 +4290,7 @@
         <p:spPr>
           <a:xfrm>
             <a:off x="731520" y="1554480"/>
-            <a:ext cx="3566160" cy="2194560"/>
+            <a:ext cx="3566160" cy="3291840"/>
           </a:xfrm>
           <a:prstGeom prst="roundRect">
             <a:avLst/>
@@ -4308,7 +4354,7 @@
                   <a:srgbClr val="182C4D"/>
                 </a:solidFill>
               </a:rPr>
-              <a:t>Operational KPIs</a:t>
+              <a:t>Phase 1 (Now)</a:t>
             </a:r>
           </a:p>
         </p:txBody>
@@ -4322,7 +4368,7 @@
         <p:spPr>
           <a:xfrm>
             <a:off x="868680" y="1965960"/>
-            <a:ext cx="3291840" cy="1691640"/>
+            <a:ext cx="3291840" cy="2788920"/>
           </a:xfrm>
           <a:prstGeom prst="rect">
             <a:avLst/>
@@ -4341,9 +4387,9 @@
                   <a:srgbClr val="182C4D"/>
                 </a:solidFill>
               </a:rPr>
-              <a:t>Avg response latency
-Policy lookup time saved
-Daily active staff users</a:t>
+              <a:t>SQLite + local storage
+Single service deployment
+Hospital-level pilot</a:t>
             </a:r>
           </a:p>
         </p:txBody>
@@ -4357,7 +4403,7 @@
         <p:spPr>
           <a:xfrm>
             <a:off x="4526280" y="1554480"/>
-            <a:ext cx="3566160" cy="2194560"/>
+            <a:ext cx="3566160" cy="3291840"/>
           </a:xfrm>
           <a:prstGeom prst="roundRect">
             <a:avLst/>
@@ -4421,7 +4467,7 @@
                   <a:srgbClr val="182C4D"/>
                 </a:solidFill>
               </a:rPr>
-              <a:t>Quality KPIs</a:t>
+              <a:t>Phase 2</a:t>
             </a:r>
           </a:p>
         </p:txBody>
@@ -4435,7 +4481,7 @@
         <p:spPr>
           <a:xfrm>
             <a:off x="4663440" y="1965960"/>
-            <a:ext cx="3291840" cy="1691640"/>
+            <a:ext cx="3291840" cy="2788920"/>
           </a:xfrm>
           <a:prstGeom prst="rect">
             <a:avLst/>
@@ -4454,9 +4500,10 @@
                   <a:srgbClr val="182C4D"/>
                 </a:solidFill>
               </a:rPr>
-              <a:t>Grounded answer rate
-Thumbs-up ratio
-Claim rejection reduction</a:t>
+              <a:t>Postgres + Redis caching
+Vector DB (Milvus/Pinecone)
+Async workers for ingestion
+Multi-hospital tenancy</a:t>
             </a:r>
           </a:p>
         </p:txBody>
@@ -4470,7 +4517,7 @@
         <p:spPr>
           <a:xfrm>
             <a:off x="8321040" y="1554480"/>
-            <a:ext cx="3108960" cy="2194560"/>
+            <a:ext cx="3108960" cy="3291840"/>
           </a:xfrm>
           <a:prstGeom prst="roundRect">
             <a:avLst/>
@@ -4534,7 +4581,7 @@
                   <a:srgbClr val="182C4D"/>
                 </a:solidFill>
               </a:rPr>
-              <a:t>Reliability KPIs</a:t>
+              <a:t>Phase 3</a:t>
             </a:r>
           </a:p>
         </p:txBody>
@@ -4548,7 +4595,7 @@
         <p:spPr>
           <a:xfrm>
             <a:off x="8458200" y="1965960"/>
-            <a:ext cx="2834640" cy="1691640"/>
+            <a:ext cx="2834640" cy="2788920"/>
           </a:xfrm>
           <a:prstGeom prst="rect">
             <a:avLst/>
@@ -4567,56 +4614,10 @@
                   <a:srgbClr val="182C4D"/>
                 </a:solidFill>
               </a:rPr>
-              <a:t>API uptime
-Error rate
-Fallback usage rate</a:t>
-            </a:r>
-          </a:p>
-        </p:txBody>
-      </p:sp>
-      <p:sp>
-        <p:nvSpPr>
-          <p:cNvPr id="14" name="TextBox 13"/>
-          <p:cNvSpPr txBox="1"/>
-          <p:nvPr/>
-        </p:nvSpPr>
-        <p:spPr>
-          <a:xfrm>
-            <a:off x="731520" y="4069080"/>
-            <a:ext cx="10698480" cy="1097280"/>
-          </a:xfrm>
-          <a:prstGeom prst="rect">
-            <a:avLst/>
-          </a:prstGeom>
-          <a:noFill/>
-        </p:spPr>
-        <p:txBody>
-          <a:bodyPr wrap="square">
-            <a:spAutoFit/>
-          </a:bodyPr>
-          <a:lstStyle/>
-          <a:p>
-            <a:pPr>
-              <a:defRPr sz="1400">
-                <a:solidFill>
-                  <a:srgbClr val="182C4D"/>
-                </a:solidFill>
-              </a:defRPr>
-            </a:pPr>
-            <a:r>
-              <a:t>Feedback loop is already implemented and directly influences retrieval ranking.</a:t>
-            </a:r>
-          </a:p>
-          <a:p>
-            <a:pPr>
-              <a:defRPr sz="1400">
-                <a:solidFill>
-                  <a:srgbClr val="182C4D"/>
-                </a:solidFill>
-              </a:defRPr>
-            </a:pPr>
-            <a:r>
-              <a:t>Next: automated evaluation set for regression testing before releases.</a:t>
+              <a:t>Horizontal autoscaling
+Regional failover
+Model routing + cost controls
+SLA/SLO observability</a:t>
             </a:r>
           </a:p>
         </p:txBody>
@@ -4675,7 +4676,7 @@
                   <a:srgbClr val="182C4D"/>
                 </a:solidFill>
               </a:rPr>
-              <a:t>Jury Questions We Are Ready For</a:t>
+              <a:t>Success Metrics</a:t>
             </a:r>
           </a:p>
         </p:txBody>
@@ -4751,21 +4752,99 @@
                   <a:srgbClr val="59636E"/>
                 </a:solidFill>
               </a:rPr>
-              <a:t>Technical depth and product-readiness</a:t>
-            </a:r>
-          </a:p>
-        </p:txBody>
-      </p:sp>
-      <p:sp>
-        <p:nvSpPr>
-          <p:cNvPr id="5" name="TextBox 4"/>
+              <a:t>What we will measure post-deployment</a:t>
+            </a:r>
+          </a:p>
+        </p:txBody>
+      </p:sp>
+      <p:sp>
+        <p:nvSpPr>
+          <p:cNvPr id="5" name="Rounded Rectangle 4"/>
+          <p:cNvSpPr/>
+          <p:nvPr/>
+        </p:nvSpPr>
+        <p:spPr>
+          <a:xfrm>
+            <a:off x="731520" y="1554480"/>
+            <a:ext cx="3566160" cy="2194560"/>
+          </a:xfrm>
+          <a:prstGeom prst="roundRect">
+            <a:avLst/>
+          </a:prstGeom>
+          <a:solidFill>
+            <a:srgbClr val="E8F1FC"/>
+          </a:solidFill>
+          <a:ln>
+            <a:solidFill>
+              <a:srgbClr val="D6DEE7"/>
+            </a:solidFill>
+          </a:ln>
+        </p:spPr>
+        <p:style>
+          <a:lnRef idx="1">
+            <a:schemeClr val="accent1"/>
+          </a:lnRef>
+          <a:fillRef idx="3">
+            <a:schemeClr val="accent1"/>
+          </a:fillRef>
+          <a:effectRef idx="2">
+            <a:schemeClr val="accent1"/>
+          </a:effectRef>
+          <a:fontRef idx="minor">
+            <a:schemeClr val="lt1"/>
+          </a:fontRef>
+        </p:style>
+        <p:txBody>
+          <a:bodyPr rtlCol="0" anchor="ctr"/>
+          <a:lstStyle/>
+          <a:p>
+            <a:pPr algn="ctr"/>
+          </a:p>
+        </p:txBody>
+      </p:sp>
+      <p:sp>
+        <p:nvSpPr>
+          <p:cNvPr id="6" name="TextBox 5"/>
           <p:cNvSpPr txBox="1"/>
           <p:nvPr/>
         </p:nvSpPr>
         <p:spPr>
           <a:xfrm>
-            <a:off x="731520" y="1737360"/>
-            <a:ext cx="10698480" cy="4389120"/>
+            <a:off x="868680" y="1645920"/>
+            <a:ext cx="3291840" cy="320040"/>
+          </a:xfrm>
+          <a:prstGeom prst="rect">
+            <a:avLst/>
+          </a:prstGeom>
+          <a:noFill/>
+        </p:spPr>
+        <p:txBody>
+          <a:bodyPr wrap="none">
+            <a:spAutoFit/>
+          </a:bodyPr>
+          <a:lstStyle/>
+          <a:p>
+            <a:r>
+              <a:rPr b="1" sz="1400">
+                <a:solidFill>
+                  <a:srgbClr val="182C4D"/>
+                </a:solidFill>
+              </a:rPr>
+              <a:t>Operational KPIs</a:t>
+            </a:r>
+          </a:p>
+        </p:txBody>
+      </p:sp>
+      <p:sp>
+        <p:nvSpPr>
+          <p:cNvPr id="7" name="TextBox 6"/>
+          <p:cNvSpPr txBox="1"/>
+          <p:nvPr/>
+        </p:nvSpPr>
+        <p:spPr>
+          <a:xfrm>
+            <a:off x="868680" y="1965960"/>
+            <a:ext cx="3291840" cy="1691640"/>
           </a:xfrm>
           <a:prstGeom prst="rect">
             <a:avLst/>
@@ -4778,63 +4857,288 @@
           </a:bodyPr>
           <a:lstStyle/>
           <a:p>
+            <a:r>
+              <a:rPr sz="1100">
+                <a:solidFill>
+                  <a:srgbClr val="182C4D"/>
+                </a:solidFill>
+              </a:rPr>
+              <a:t>Avg response latency
+Policy lookup time saved
+Daily active staff users</a:t>
+            </a:r>
+          </a:p>
+        </p:txBody>
+      </p:sp>
+      <p:sp>
+        <p:nvSpPr>
+          <p:cNvPr id="8" name="Rounded Rectangle 7"/>
+          <p:cNvSpPr/>
+          <p:nvPr/>
+        </p:nvSpPr>
+        <p:spPr>
+          <a:xfrm>
+            <a:off x="4526280" y="1554480"/>
+            <a:ext cx="3566160" cy="2194560"/>
+          </a:xfrm>
+          <a:prstGeom prst="roundRect">
+            <a:avLst/>
+          </a:prstGeom>
+          <a:solidFill>
+            <a:srgbClr val="EAF6EE"/>
+          </a:solidFill>
+          <a:ln>
+            <a:solidFill>
+              <a:srgbClr val="D6DEE7"/>
+            </a:solidFill>
+          </a:ln>
+        </p:spPr>
+        <p:style>
+          <a:lnRef idx="1">
+            <a:schemeClr val="accent1"/>
+          </a:lnRef>
+          <a:fillRef idx="3">
+            <a:schemeClr val="accent1"/>
+          </a:fillRef>
+          <a:effectRef idx="2">
+            <a:schemeClr val="accent1"/>
+          </a:effectRef>
+          <a:fontRef idx="minor">
+            <a:schemeClr val="lt1"/>
+          </a:fontRef>
+        </p:style>
+        <p:txBody>
+          <a:bodyPr rtlCol="0" anchor="ctr"/>
+          <a:lstStyle/>
+          <a:p>
+            <a:pPr algn="ctr"/>
+          </a:p>
+        </p:txBody>
+      </p:sp>
+      <p:sp>
+        <p:nvSpPr>
+          <p:cNvPr id="9" name="TextBox 8"/>
+          <p:cNvSpPr txBox="1"/>
+          <p:nvPr/>
+        </p:nvSpPr>
+        <p:spPr>
+          <a:xfrm>
+            <a:off x="4663440" y="1645920"/>
+            <a:ext cx="3291840" cy="320040"/>
+          </a:xfrm>
+          <a:prstGeom prst="rect">
+            <a:avLst/>
+          </a:prstGeom>
+          <a:noFill/>
+        </p:spPr>
+        <p:txBody>
+          <a:bodyPr wrap="none">
+            <a:spAutoFit/>
+          </a:bodyPr>
+          <a:lstStyle/>
+          <a:p>
+            <a:r>
+              <a:rPr b="1" sz="1400">
+                <a:solidFill>
+                  <a:srgbClr val="182C4D"/>
+                </a:solidFill>
+              </a:rPr>
+              <a:t>Quality KPIs</a:t>
+            </a:r>
+          </a:p>
+        </p:txBody>
+      </p:sp>
+      <p:sp>
+        <p:nvSpPr>
+          <p:cNvPr id="10" name="TextBox 9"/>
+          <p:cNvSpPr txBox="1"/>
+          <p:nvPr/>
+        </p:nvSpPr>
+        <p:spPr>
+          <a:xfrm>
+            <a:off x="4663440" y="1965960"/>
+            <a:ext cx="3291840" cy="1691640"/>
+          </a:xfrm>
+          <a:prstGeom prst="rect">
+            <a:avLst/>
+          </a:prstGeom>
+          <a:noFill/>
+        </p:spPr>
+        <p:txBody>
+          <a:bodyPr wrap="square">
+            <a:spAutoFit/>
+          </a:bodyPr>
+          <a:lstStyle/>
+          <a:p>
+            <a:r>
+              <a:rPr sz="1100">
+                <a:solidFill>
+                  <a:srgbClr val="182C4D"/>
+                </a:solidFill>
+              </a:rPr>
+              <a:t>Grounded answer rate
+Thumbs-up ratio
+Claim rejection reduction</a:t>
+            </a:r>
+          </a:p>
+        </p:txBody>
+      </p:sp>
+      <p:sp>
+        <p:nvSpPr>
+          <p:cNvPr id="11" name="Rounded Rectangle 10"/>
+          <p:cNvSpPr/>
+          <p:nvPr/>
+        </p:nvSpPr>
+        <p:spPr>
+          <a:xfrm>
+            <a:off x="8321040" y="1554480"/>
+            <a:ext cx="3108960" cy="2194560"/>
+          </a:xfrm>
+          <a:prstGeom prst="roundRect">
+            <a:avLst/>
+          </a:prstGeom>
+          <a:solidFill>
+            <a:srgbClr val="FFF4E8"/>
+          </a:solidFill>
+          <a:ln>
+            <a:solidFill>
+              <a:srgbClr val="D6DEE7"/>
+            </a:solidFill>
+          </a:ln>
+        </p:spPr>
+        <p:style>
+          <a:lnRef idx="1">
+            <a:schemeClr val="accent1"/>
+          </a:lnRef>
+          <a:fillRef idx="3">
+            <a:schemeClr val="accent1"/>
+          </a:fillRef>
+          <a:effectRef idx="2">
+            <a:schemeClr val="accent1"/>
+          </a:effectRef>
+          <a:fontRef idx="minor">
+            <a:schemeClr val="lt1"/>
+          </a:fontRef>
+        </p:style>
+        <p:txBody>
+          <a:bodyPr rtlCol="0" anchor="ctr"/>
+          <a:lstStyle/>
+          <a:p>
+            <a:pPr algn="ctr"/>
+          </a:p>
+        </p:txBody>
+      </p:sp>
+      <p:sp>
+        <p:nvSpPr>
+          <p:cNvPr id="12" name="TextBox 11"/>
+          <p:cNvSpPr txBox="1"/>
+          <p:nvPr/>
+        </p:nvSpPr>
+        <p:spPr>
+          <a:xfrm>
+            <a:off x="8458200" y="1645920"/>
+            <a:ext cx="2834640" cy="320040"/>
+          </a:xfrm>
+          <a:prstGeom prst="rect">
+            <a:avLst/>
+          </a:prstGeom>
+          <a:noFill/>
+        </p:spPr>
+        <p:txBody>
+          <a:bodyPr wrap="none">
+            <a:spAutoFit/>
+          </a:bodyPr>
+          <a:lstStyle/>
+          <a:p>
+            <a:r>
+              <a:rPr b="1" sz="1400">
+                <a:solidFill>
+                  <a:srgbClr val="182C4D"/>
+                </a:solidFill>
+              </a:rPr>
+              <a:t>Reliability KPIs</a:t>
+            </a:r>
+          </a:p>
+        </p:txBody>
+      </p:sp>
+      <p:sp>
+        <p:nvSpPr>
+          <p:cNvPr id="13" name="TextBox 12"/>
+          <p:cNvSpPr txBox="1"/>
+          <p:nvPr/>
+        </p:nvSpPr>
+        <p:spPr>
+          <a:xfrm>
+            <a:off x="8458200" y="1965960"/>
+            <a:ext cx="2834640" cy="1691640"/>
+          </a:xfrm>
+          <a:prstGeom prst="rect">
+            <a:avLst/>
+          </a:prstGeom>
+          <a:noFill/>
+        </p:spPr>
+        <p:txBody>
+          <a:bodyPr wrap="square">
+            <a:spAutoFit/>
+          </a:bodyPr>
+          <a:lstStyle/>
+          <a:p>
+            <a:r>
+              <a:rPr sz="1100">
+                <a:solidFill>
+                  <a:srgbClr val="182C4D"/>
+                </a:solidFill>
+              </a:rPr>
+              <a:t>API uptime
+Error rate
+Fallback usage rate</a:t>
+            </a:r>
+          </a:p>
+        </p:txBody>
+      </p:sp>
+      <p:sp>
+        <p:nvSpPr>
+          <p:cNvPr id="14" name="TextBox 13"/>
+          <p:cNvSpPr txBox="1"/>
+          <p:nvPr/>
+        </p:nvSpPr>
+        <p:spPr>
+          <a:xfrm>
+            <a:off x="731520" y="4069080"/>
+            <a:ext cx="10698480" cy="1097280"/>
+          </a:xfrm>
+          <a:prstGeom prst="rect">
+            <a:avLst/>
+          </a:prstGeom>
+          <a:noFill/>
+        </p:spPr>
+        <p:txBody>
+          <a:bodyPr wrap="square">
+            <a:spAutoFit/>
+          </a:bodyPr>
+          <a:lstStyle/>
+          <a:p>
             <a:pPr>
-              <a:defRPr sz="1600">
+              <a:defRPr sz="1400">
                 <a:solidFill>
                   <a:srgbClr val="182C4D"/>
                 </a:solidFill>
               </a:defRPr>
             </a:pPr>
             <a:r>
-              <a:t>How do you prevent hallucination? -&gt; Grounded retrieval + source evidence + no-info fallback.</a:t>
+              <a:t>Feedback loop is already implemented and directly influences retrieval ranking.</a:t>
             </a:r>
           </a:p>
           <a:p>
             <a:pPr>
-              <a:defRPr sz="1600">
+              <a:defRPr sz="1400">
                 <a:solidFill>
                   <a:srgbClr val="182C4D"/>
                 </a:solidFill>
               </a:defRPr>
             </a:pPr>
             <a:r>
-              <a:t>How is multilingual handled? -&gt; Sarvam translation + language detection + voice STT/TTS.</a:t>
-            </a:r>
-          </a:p>
-          <a:p>
-            <a:pPr>
-              <a:defRPr sz="1600">
-                <a:solidFill>
-                  <a:srgbClr val="182C4D"/>
-                </a:solidFill>
-              </a:defRPr>
-            </a:pPr>
-            <a:r>
-              <a:t>How do you secure hospital data? -&gt; Auth, RBAC, controlled upload, audit logs.</a:t>
-            </a:r>
-          </a:p>
-          <a:p>
-            <a:pPr>
-              <a:defRPr sz="1600">
-                <a:solidFill>
-                  <a:srgbClr val="182C4D"/>
-                </a:solidFill>
-              </a:defRPr>
-            </a:pPr>
-            <a:r>
-              <a:t>How will this scale beyond one hospital? -&gt; DB upgrade, vector DB, async ingestion, multi-tenant architecture.</a:t>
-            </a:r>
-          </a:p>
-          <a:p>
-            <a:pPr>
-              <a:defRPr sz="1600">
-                <a:solidFill>
-                  <a:srgbClr val="182C4D"/>
-                </a:solidFill>
-              </a:defRPr>
-            </a:pPr>
-            <a:r>
-              <a:t>What is the ROI? -&gt; Faster claim processing, lower rejection, reduced policy lookup time.</a:t>
+              <a:t>Next: automated evaluation set for regression testing before releases.</a:t>
             </a:r>
           </a:p>
         </p:txBody>
@@ -4848,6 +5152,224 @@
 </file>
 
 <file path=ppt/slides/slide13.xml><?xml version="1.0" encoding="utf-8"?>
+<p:sld xmlns:a="http://schemas.openxmlformats.org/drawingml/2006/main" xmlns:p="http://schemas.openxmlformats.org/presentationml/2006/main" xmlns:r="http://schemas.openxmlformats.org/officeDocument/2006/relationships">
+  <p:cSld>
+    <p:bg>
+      <p:bgPr>
+        <a:solidFill>
+          <a:srgbClr val="FFFFFF"/>
+        </a:solidFill>
+        <a:effectLst/>
+      </p:bgPr>
+    </p:bg>
+    <p:spTree>
+      <p:nvGrpSpPr>
+        <p:cNvPr id="1" name=""/>
+        <p:cNvGrpSpPr/>
+        <p:nvPr/>
+      </p:nvGrpSpPr>
+      <p:grpSpPr/>
+      <p:sp>
+        <p:nvSpPr>
+          <p:cNvPr id="2" name="TextBox 1"/>
+          <p:cNvSpPr txBox="1"/>
+          <p:nvPr/>
+        </p:nvSpPr>
+        <p:spPr>
+          <a:xfrm>
+            <a:off x="548640" y="228600"/>
+            <a:ext cx="10972800" cy="640080"/>
+          </a:xfrm>
+          <a:prstGeom prst="rect">
+            <a:avLst/>
+          </a:prstGeom>
+          <a:noFill/>
+        </p:spPr>
+        <p:txBody>
+          <a:bodyPr wrap="none">
+            <a:spAutoFit/>
+          </a:bodyPr>
+          <a:lstStyle/>
+          <a:p>
+            <a:r>
+              <a:rPr sz="2800" b="1">
+                <a:solidFill>
+                  <a:srgbClr val="182C4D"/>
+                </a:solidFill>
+              </a:rPr>
+              <a:t>Jury Questions We Are Ready For</a:t>
+            </a:r>
+          </a:p>
+        </p:txBody>
+      </p:sp>
+      <p:sp>
+        <p:nvSpPr>
+          <p:cNvPr id="3" name="Rectangle 2"/>
+          <p:cNvSpPr/>
+          <p:nvPr/>
+        </p:nvSpPr>
+        <p:spPr>
+          <a:xfrm>
+            <a:off x="548640" y="932688"/>
+            <a:ext cx="2560320" cy="64008"/>
+          </a:xfrm>
+          <a:prstGeom prst="rect">
+            <a:avLst/>
+          </a:prstGeom>
+          <a:solidFill>
+            <a:srgbClr val="00897B"/>
+          </a:solidFill>
+          <a:ln>
+            <a:noFill/>
+          </a:ln>
+        </p:spPr>
+        <p:style>
+          <a:lnRef idx="1">
+            <a:schemeClr val="accent1"/>
+          </a:lnRef>
+          <a:fillRef idx="3">
+            <a:schemeClr val="accent1"/>
+          </a:fillRef>
+          <a:effectRef idx="2">
+            <a:schemeClr val="accent1"/>
+          </a:effectRef>
+          <a:fontRef idx="minor">
+            <a:schemeClr val="lt1"/>
+          </a:fontRef>
+        </p:style>
+        <p:txBody>
+          <a:bodyPr rtlCol="0" anchor="ctr"/>
+          <a:lstStyle/>
+          <a:p>
+            <a:pPr algn="ctr"/>
+          </a:p>
+        </p:txBody>
+      </p:sp>
+      <p:sp>
+        <p:nvSpPr>
+          <p:cNvPr id="4" name="TextBox 3"/>
+          <p:cNvSpPr txBox="1"/>
+          <p:nvPr/>
+        </p:nvSpPr>
+        <p:spPr>
+          <a:xfrm>
+            <a:off x="548640" y="1051560"/>
+            <a:ext cx="11064240" cy="457200"/>
+          </a:xfrm>
+          <a:prstGeom prst="rect">
+            <a:avLst/>
+          </a:prstGeom>
+          <a:noFill/>
+        </p:spPr>
+        <p:txBody>
+          <a:bodyPr wrap="none">
+            <a:spAutoFit/>
+          </a:bodyPr>
+          <a:lstStyle/>
+          <a:p>
+            <a:r>
+              <a:rPr sz="1200">
+                <a:solidFill>
+                  <a:srgbClr val="59636E"/>
+                </a:solidFill>
+              </a:rPr>
+              <a:t>Technical depth and product-readiness</a:t>
+            </a:r>
+          </a:p>
+        </p:txBody>
+      </p:sp>
+      <p:sp>
+        <p:nvSpPr>
+          <p:cNvPr id="5" name="TextBox 4"/>
+          <p:cNvSpPr txBox="1"/>
+          <p:nvPr/>
+        </p:nvSpPr>
+        <p:spPr>
+          <a:xfrm>
+            <a:off x="731520" y="1737360"/>
+            <a:ext cx="10698480" cy="4389120"/>
+          </a:xfrm>
+          <a:prstGeom prst="rect">
+            <a:avLst/>
+          </a:prstGeom>
+          <a:noFill/>
+        </p:spPr>
+        <p:txBody>
+          <a:bodyPr wrap="square">
+            <a:spAutoFit/>
+          </a:bodyPr>
+          <a:lstStyle/>
+          <a:p>
+            <a:pPr>
+              <a:defRPr sz="1600">
+                <a:solidFill>
+                  <a:srgbClr val="182C4D"/>
+                </a:solidFill>
+              </a:defRPr>
+            </a:pPr>
+            <a:r>
+              <a:t>How do you prevent hallucination? -&gt; Grounded retrieval + source evidence + no-info fallback.</a:t>
+            </a:r>
+          </a:p>
+          <a:p>
+            <a:pPr>
+              <a:defRPr sz="1600">
+                <a:solidFill>
+                  <a:srgbClr val="182C4D"/>
+                </a:solidFill>
+              </a:defRPr>
+            </a:pPr>
+            <a:r>
+              <a:t>How is multilingual handled? -&gt; Sarvam translation + language detection + voice STT/TTS.</a:t>
+            </a:r>
+          </a:p>
+          <a:p>
+            <a:pPr>
+              <a:defRPr sz="1600">
+                <a:solidFill>
+                  <a:srgbClr val="182C4D"/>
+                </a:solidFill>
+              </a:defRPr>
+            </a:pPr>
+            <a:r>
+              <a:t>How do you secure hospital data? -&gt; Auth, RBAC, controlled upload, audit logs.</a:t>
+            </a:r>
+          </a:p>
+          <a:p>
+            <a:pPr>
+              <a:defRPr sz="1600">
+                <a:solidFill>
+                  <a:srgbClr val="182C4D"/>
+                </a:solidFill>
+              </a:defRPr>
+            </a:pPr>
+            <a:r>
+              <a:t>How will this scale beyond one hospital? -&gt; DB upgrade, vector DB, async ingestion, multi-tenant architecture.</a:t>
+            </a:r>
+          </a:p>
+          <a:p>
+            <a:pPr>
+              <a:defRPr sz="1600">
+                <a:solidFill>
+                  <a:srgbClr val="182C4D"/>
+                </a:solidFill>
+              </a:defRPr>
+            </a:pPr>
+            <a:r>
+              <a:t>What is the ROI? -&gt; Faster claim processing, lower rejection, reduced policy lookup time.</a:t>
+            </a:r>
+          </a:p>
+        </p:txBody>
+      </p:sp>
+    </p:spTree>
+  </p:cSld>
+  <p:clrMapOvr>
+    <a:masterClrMapping/>
+  </p:clrMapOvr>
+</p:sld>
+</file>
+
+<file path=ppt/slides/slide14.xml><?xml version="1.0" encoding="utf-8"?>
 <p:sld xmlns:a="http://schemas.openxmlformats.org/drawingml/2006/main" xmlns:p="http://schemas.openxmlformats.org/presentationml/2006/main" xmlns:r="http://schemas.openxmlformats.org/officeDocument/2006/relationships">
   <p:cSld>
     <p:bg>
@@ -8668,7 +9190,7 @@
                   <a:srgbClr val="182C4D"/>
                 </a:solidFill>
               </a:rPr>
-              <a:t>Deployment Plan</a:t>
+              <a:t>Guardrails: Sensitivity Labels + Access Fallback</a:t>
             </a:r>
           </a:p>
         </p:txBody>
@@ -8744,7 +9266,7 @@
                   <a:srgbClr val="59636E"/>
                 </a:solidFill>
               </a:rPr>
-              <a:t>Where and how Policy Sarthi will run</a:t>
+              <a:t>Explicit data control per role</a:t>
             </a:r>
           </a:p>
         </p:txBody>
@@ -8758,7 +9280,7 @@
         <p:spPr>
           <a:xfrm>
             <a:off x="731520" y="1554480"/>
-            <a:ext cx="3474720" cy="2194560"/>
+            <a:ext cx="5212080" cy="2560320"/>
           </a:xfrm>
           <a:prstGeom prst="roundRect">
             <a:avLst/>
@@ -8803,7 +9325,7 @@
         <p:spPr>
           <a:xfrm>
             <a:off x="868680" y="1645920"/>
-            <a:ext cx="3200400" cy="320040"/>
+            <a:ext cx="4937760" cy="320040"/>
           </a:xfrm>
           <a:prstGeom prst="rect">
             <a:avLst/>
@@ -8822,7 +9344,7 @@
                   <a:srgbClr val="182C4D"/>
                 </a:solidFill>
               </a:rPr>
-              <a:t>MVP Deployment</a:t>
+              <a:t>Sensitivity Labels</a:t>
             </a:r>
           </a:p>
         </p:txBody>
@@ -8836,7 +9358,7 @@
         <p:spPr>
           <a:xfrm>
             <a:off x="868680" y="1965960"/>
-            <a:ext cx="3200400" cy="1691640"/>
+            <a:ext cx="4937760" cy="2057400"/>
           </a:xfrm>
           <a:prstGeom prst="rect">
             <a:avLst/>
@@ -8855,9 +9377,11 @@
                   <a:srgbClr val="182C4D"/>
                 </a:solidFill>
               </a:rPr>
-              <a:t>Single VM/Container
-Frontend + Backend behind reverse proxy
-Managed secrets for Sarvam key</a:t>
+              <a:t>public -&gt; admin/staff/auditor/user
+internal -&gt; admin/staff/auditor
+confidential -&gt; admin/staff
+restricted -&gt; admin only
+Admin selects label at upload time.</a:t>
             </a:r>
           </a:p>
         </p:txBody>
@@ -8870,121 +9394,8 @@
         </p:nvSpPr>
         <p:spPr>
           <a:xfrm>
-            <a:off x="4526280" y="1554480"/>
-            <a:ext cx="3474720" cy="2194560"/>
-          </a:xfrm>
-          <a:prstGeom prst="roundRect">
-            <a:avLst/>
-          </a:prstGeom>
-          <a:solidFill>
-            <a:srgbClr val="EAF6EE"/>
-          </a:solidFill>
-          <a:ln>
-            <a:solidFill>
-              <a:srgbClr val="D6DEE7"/>
-            </a:solidFill>
-          </a:ln>
-        </p:spPr>
-        <p:style>
-          <a:lnRef idx="1">
-            <a:schemeClr val="accent1"/>
-          </a:lnRef>
-          <a:fillRef idx="3">
-            <a:schemeClr val="accent1"/>
-          </a:fillRef>
-          <a:effectRef idx="2">
-            <a:schemeClr val="accent1"/>
-          </a:effectRef>
-          <a:fontRef idx="minor">
-            <a:schemeClr val="lt1"/>
-          </a:fontRef>
-        </p:style>
-        <p:txBody>
-          <a:bodyPr rtlCol="0" anchor="ctr"/>
-          <a:lstStyle/>
-          <a:p>
-            <a:pPr algn="ctr"/>
-          </a:p>
-        </p:txBody>
-      </p:sp>
-      <p:sp>
-        <p:nvSpPr>
-          <p:cNvPr id="9" name="TextBox 8"/>
-          <p:cNvSpPr txBox="1"/>
-          <p:nvPr/>
-        </p:nvSpPr>
-        <p:spPr>
-          <a:xfrm>
-            <a:off x="4663440" y="1645920"/>
-            <a:ext cx="3200400" cy="320040"/>
-          </a:xfrm>
-          <a:prstGeom prst="rect">
-            <a:avLst/>
-          </a:prstGeom>
-          <a:noFill/>
-        </p:spPr>
-        <p:txBody>
-          <a:bodyPr wrap="none">
-            <a:spAutoFit/>
-          </a:bodyPr>
-          <a:lstStyle/>
-          <a:p>
-            <a:r>
-              <a:rPr b="1" sz="1400">
-                <a:solidFill>
-                  <a:srgbClr val="182C4D"/>
-                </a:solidFill>
-              </a:rPr>
-              <a:t>Preferred Cloud</a:t>
-            </a:r>
-          </a:p>
-        </p:txBody>
-      </p:sp>
-      <p:sp>
-        <p:nvSpPr>
-          <p:cNvPr id="10" name="TextBox 9"/>
-          <p:cNvSpPr txBox="1"/>
-          <p:nvPr/>
-        </p:nvSpPr>
-        <p:spPr>
-          <a:xfrm>
-            <a:off x="4663440" y="1965960"/>
-            <a:ext cx="3200400" cy="1691640"/>
-          </a:xfrm>
-          <a:prstGeom prst="rect">
-            <a:avLst/>
-          </a:prstGeom>
-          <a:noFill/>
-        </p:spPr>
-        <p:txBody>
-          <a:bodyPr wrap="square">
-            <a:spAutoFit/>
-          </a:bodyPr>
-          <a:lstStyle/>
-          <a:p>
-            <a:r>
-              <a:rPr sz="1100">
-                <a:solidFill>
-                  <a:srgbClr val="182C4D"/>
-                </a:solidFill>
-              </a:rPr>
-              <a:t>Azure / AWS / GCP
-App service + managed DB + object storage
-CI/CD via GitHub Actions</a:t>
-            </a:r>
-          </a:p>
-        </p:txBody>
-      </p:sp>
-      <p:sp>
-        <p:nvSpPr>
-          <p:cNvPr id="11" name="Rounded Rectangle 10"/>
-          <p:cNvSpPr/>
-          <p:nvPr/>
-        </p:nvSpPr>
-        <p:spPr>
-          <a:xfrm>
-            <a:off x="8321040" y="1554480"/>
-            <a:ext cx="3108960" cy="2194560"/>
+            <a:off x="6172200" y="1554480"/>
+            <a:ext cx="5257800" cy="2560320"/>
           </a:xfrm>
           <a:prstGeom prst="roundRect">
             <a:avLst/>
@@ -9022,14 +9433,14 @@
       </p:sp>
       <p:sp>
         <p:nvSpPr>
-          <p:cNvPr id="12" name="TextBox 11"/>
+          <p:cNvPr id="9" name="TextBox 8"/>
           <p:cNvSpPr txBox="1"/>
           <p:nvPr/>
         </p:nvSpPr>
         <p:spPr>
           <a:xfrm>
-            <a:off x="8458200" y="1645920"/>
-            <a:ext cx="2834640" cy="320040"/>
+            <a:off x="6309360" y="1645920"/>
+            <a:ext cx="4983480" cy="320040"/>
           </a:xfrm>
           <a:prstGeom prst="rect">
             <a:avLst/>
@@ -9048,21 +9459,21 @@
                   <a:srgbClr val="182C4D"/>
                 </a:solidFill>
               </a:rPr>
-              <a:t>Hospital Integration</a:t>
-            </a:r>
-          </a:p>
-        </p:txBody>
-      </p:sp>
-      <p:sp>
-        <p:nvSpPr>
-          <p:cNvPr id="13" name="TextBox 12"/>
+              <a:t>Unauthorized Access Handling</a:t>
+            </a:r>
+          </a:p>
+        </p:txBody>
+      </p:sp>
+      <p:sp>
+        <p:nvSpPr>
+          <p:cNvPr id="10" name="TextBox 9"/>
           <p:cNvSpPr txBox="1"/>
           <p:nvPr/>
         </p:nvSpPr>
         <p:spPr>
           <a:xfrm>
-            <a:off x="8458200" y="1965960"/>
-            <a:ext cx="2834640" cy="1691640"/>
+            <a:off x="6309360" y="1965960"/>
+            <a:ext cx="4983480" cy="2057400"/>
           </a:xfrm>
           <a:prstGeom prst="rect">
             <a:avLst/>
@@ -9081,23 +9492,23 @@
                   <a:srgbClr val="182C4D"/>
                 </a:solidFill>
               </a:rPr>
-              <a:t>VPN/private network
-SSO with hospital IAM
-Audit export to SIEM</a:t>
-            </a:r>
-          </a:p>
-        </p:txBody>
-      </p:sp>
-      <p:sp>
-        <p:nvSpPr>
-          <p:cNvPr id="14" name="TextBox 13"/>
+              <a:t>If a query matches only restricted documents outside the user role, the assistant does NOT expose content.
+Fallback response:
+'Information exists, but your role is not authorized for this sensitivity level. Please contact admin.'</a:t>
+            </a:r>
+          </a:p>
+        </p:txBody>
+      </p:sp>
+      <p:sp>
+        <p:nvSpPr>
+          <p:cNvPr id="11" name="TextBox 10"/>
           <p:cNvSpPr txBox="1"/>
           <p:nvPr/>
         </p:nvSpPr>
         <p:spPr>
           <a:xfrm>
-            <a:off x="731520" y="4069080"/>
-            <a:ext cx="10698480" cy="1188720"/>
+            <a:off x="731520" y="4480560"/>
+            <a:ext cx="10698480" cy="1005840"/>
           </a:xfrm>
           <a:prstGeom prst="rect">
             <a:avLst/>
@@ -9118,7 +9529,7 @@
               </a:defRPr>
             </a:pPr>
             <a:r>
-              <a:t>Target environments: staging (UAT) -&gt; production with change approvals.</a:t>
+              <a:t>This avoids accidental leakage while keeping staff/admin productivity for permitted data.</a:t>
             </a:r>
           </a:p>
           <a:p>
@@ -9130,7 +9541,7 @@
               </a:defRPr>
             </a:pPr>
             <a:r>
-              <a:t>Secrets, logs, and backups managed through cloud-native services.</a:t>
+              <a:t>Guardrail decision happens before final answer generation.</a:t>
             </a:r>
           </a:p>
         </p:txBody>

</xml_diff>